<commit_message>
Update files for Delta Higher Institute (remove Tanta University references)
Co-Authored-By: Claude Sonnet 5.5 <noreply@anthropic.com>
Claude-Session: https://claude.ai/code/session_0185BhYAfF4xFuPNPfvWLvUn
</commit_message>
<xml_diff>
--- a/sustainability-family-deck.pptx
+++ b/sustainability-family-deck.pptx
@@ -597,7 +597,7 @@
           <a:p>
             <a:r>
               <a:rPr lang="en-US" dirty="0"/>
-              <a:t>الأرقام من إعلان الجامعة على لينكدإن عن تصنيف 2026. اربطي الفكرة بأن مساهمة المعهد ترفع نقاط الجامعة.</a:t>
+              <a:t>الأرقام من إعلان رسمي لإحدى الجامعات المصرية عن نسخة 2026 (2016 مؤسسة من 110 دولة، و47 جامعة مصرية). راجعي موقع UI GreenMetric للأرقام المحدثة.</a:t>
             </a:r>
             <a:endParaRPr lang="en-US" dirty="0"/>
           </a:p>
@@ -1595,7 +1595,7 @@
                 <a:ea typeface="Arial" pitchFamily="34" charset="-122"/>
                 <a:cs typeface="Arial" pitchFamily="34" charset="-120"/>
               </a:rPr>
-              <a:t>المعهد الهندسي: نحو معهد منخفض البصمة الكربونية</a:t>
+              <a:t>معهد الدلتا العالي للهندسة والتكنولوجيا  |  نحو معهد منخفض البصمة الكربونية</a:t>
             </a:r>
             <a:endParaRPr lang="en-US" sz="2400" dirty="0"/>
           </a:p>
@@ -1744,7 +1744,7 @@
                 <a:ea typeface="Arial" pitchFamily="34" charset="-122"/>
                 <a:cs typeface="Arial" pitchFamily="34" charset="-120"/>
               </a:rPr>
-              <a:t>جامعة طنطا في UI GreenMetric 2026</a:t>
+              <a:t>التصنيف العالمي للاستدامة UI GreenMetric 2026: حجم المنافسة</a:t>
             </a:r>
             <a:endParaRPr lang="en-US" sz="1800" dirty="0"/>
           </a:p>
@@ -1810,7 +1810,7 @@
                 <a:ea typeface="Arial" pitchFamily="34" charset="-122"/>
                 <a:cs typeface="Arial" pitchFamily="34" charset="-120"/>
               </a:rPr>
-              <a:t>589</a:t>
+              <a:t>2016</a:t>
             </a:r>
             <a:endParaRPr lang="en-US" sz="6000" dirty="0"/>
           </a:p>
@@ -1849,7 +1849,7 @@
                 <a:ea typeface="Arial" pitchFamily="34" charset="-122"/>
                 <a:cs typeface="Arial" pitchFamily="34" charset="-120"/>
               </a:rPr>
-              <a:t>عالميًا من بين 2016 مؤسسة</a:t>
+              <a:t>مؤسسة تعليمية مصنَّفة</a:t>
             </a:r>
             <a:endParaRPr lang="en-US" sz="1400" dirty="0"/>
           </a:p>
@@ -1915,7 +1915,7 @@
                 <a:ea typeface="Arial" pitchFamily="34" charset="-122"/>
                 <a:cs typeface="Arial" pitchFamily="34" charset="-120"/>
               </a:rPr>
-              <a:t>18</a:t>
+              <a:t>110</a:t>
             </a:r>
             <a:endParaRPr lang="en-US" sz="6000" dirty="0"/>
           </a:p>
@@ -1954,7 +1954,7 @@
                 <a:ea typeface="Arial" pitchFamily="34" charset="-122"/>
                 <a:cs typeface="Arial" pitchFamily="34" charset="-120"/>
               </a:rPr>
-              <a:t>إفريقيًا من بين 127 جامعة</a:t>
+              <a:t>دولة حول العالم</a:t>
             </a:r>
             <a:endParaRPr lang="en-US" sz="1400" dirty="0"/>
           </a:p>
@@ -2020,7 +2020,7 @@
                 <a:ea typeface="Arial" pitchFamily="34" charset="-122"/>
                 <a:cs typeface="Arial" pitchFamily="34" charset="-120"/>
               </a:rPr>
-              <a:t>14</a:t>
+              <a:t>47</a:t>
             </a:r>
             <a:endParaRPr lang="en-US" sz="6000" dirty="0"/>
           </a:p>
@@ -2059,7 +2059,7 @@
                 <a:ea typeface="Arial" pitchFamily="34" charset="-122"/>
                 <a:cs typeface="Arial" pitchFamily="34" charset="-120"/>
               </a:rPr>
-              <a:t>محليًا من بين 47 جامعة مصرية</a:t>
+              <a:t>جامعة مصرية مشاركة</a:t>
             </a:r>
             <a:endParaRPr lang="en-US" sz="1400" dirty="0"/>
           </a:p>
@@ -2098,7 +2098,7 @@
                 <a:ea typeface="Arial" pitchFamily="34" charset="-122"/>
                 <a:cs typeface="Arial" pitchFamily="34" charset="-120"/>
               </a:rPr>
-              <a:t>كل معهد يضيف نقاطًا للجامعة. معهدنا الهندسي قادر على أن يكون نموذجًا يُحتذى.</a:t>
+              <a:t>فرصة لمعهدنا للانضمام لهذه المنافسة وإثبات التزامه بالاستدامة.</a:t>
             </a:r>
             <a:endParaRPr lang="en-US" sz="2000" dirty="0"/>
           </a:p>
@@ -6131,7 +6131,7 @@
                 <a:ea typeface="Arial" pitchFamily="34" charset="-122"/>
                 <a:cs typeface="Arial" pitchFamily="34" charset="-120"/>
               </a:rPr>
-              <a:t>التنسيق مع مكتب الاستدامة بجامعة طنطا</a:t>
+              <a:t>تعيين منسق للمعهد للتواصل مع UI GreenMetric</a:t>
             </a:r>
             <a:endParaRPr lang="en-US" sz="1800" dirty="0"/>
           </a:p>

</xml_diff>